<commit_message>
Thesis: clearer title without "Bangla-first", Times New Roman throughout, and every table rewritten in plain words.
- Title: "SARA (Smart Assistive Reading Aid): An Offline Smart Glass for Visually Impaired People that Reads Bangla and English Text, Detects Objects, and Recognises and Checks Bangladeshi Taka Notes" (report and slides).
- XeLaTeX with Times New Roman for text, headings, numbers in formulas, "%" and accents.
- Table 2.11.0.1 gets a picture column and plain-language columns; Table 2.11.0.2 names all 9 types of Bangladeshi notes (BDT) and explains mAP, precision and recall.
- All other tables: plain headers and cells, same numbers; Grad-CAM row corrected to the Taka detector.

Co-Authored-By: Claude Opus 5.5 <noreply@anthropic.com>
</commit_message>
<xml_diff>
--- a/Thesis Report and paper/thesis report/slides/SARA_Presentation.pptx
+++ b/Thesis Report and paper/thesis report/slides/SARA_Presentation.pptx
@@ -124,7 +124,7 @@
   <p:extLst>
     <p:ext uri="{521415D9-36F7-43E2-AB2F-B90AF26B5E84}">
       <p14:sectionLst xmlns:p14="http://schemas.microsoft.com/office/powerpoint/2010/main">
-        <p14:section name="Introduction" id="{53c1f99b-8a29-f4fe-3a8c-3853c35f632f}">
+        <p14:section name="Introduction" id="{761c2567-bf24-4448-e7a5-a4b4c6953bb9}">
           <p14:sldIdLst>
             <p14:sldId id="256"/>
             <p14:sldId id="257"/>
@@ -132,18 +132,18 @@
             <p14:sldId id="259"/>
           </p14:sldIdLst>
         </p14:section>
-        <p14:section name="Background" id="{40e3bcf0-8828-c15b-f5fb-ca44ba598154}">
+        <p14:section name="Background" id="{40385f4d-45e1-9548-eb8d-cfa53aa8e81b}">
           <p14:sldIdLst>
             <p14:sldId id="260"/>
           </p14:sldIdLst>
         </p14:section>
-        <p14:section name="System" id="{b71a5a4e-99aa-763c-551b-90190d6cebe7}">
+        <p14:section name="System" id="{fd1278ef-ba4c-8490-8e05-0d24a5c334ed}">
           <p14:sldIdLst>
             <p14:sldId id="261"/>
             <p14:sldId id="262"/>
           </p14:sldIdLst>
         </p14:section>
-        <p14:section name="Results" id="{5b16eee3-b930-038f-5464-fbdc679cf217}">
+        <p14:section name="Results" id="{78de5ec4-93b5-7b76-92bc-cc344e16a60a}">
           <p14:sldIdLst>
             <p14:sldId id="263"/>
             <p14:sldId id="264"/>
@@ -154,12 +154,12 @@
             <p14:sldId id="269"/>
           </p14:sldIdLst>
         </p14:section>
-        <p14:section name="Testing" id="{894da795-8fb1-89e6-5bf0-4f1cc6d7d671}">
+        <p14:section name="Testing" id="{fbe42ea3-64ec-2023-b6e4-2e2587b3e231}">
           <p14:sldIdLst>
             <p14:sldId id="270"/>
           </p14:sldIdLst>
         </p14:section>
-        <p14:section name="Conclusion" id="{cbc7bb76-fab4-8026-e95f-40bc55cfc19f}">
+        <p14:section name="Conclusion" id="{c18cd6bc-ab02-6efe-09f9-c70b605c0f96}">
           <p14:sldIdLst>
             <p14:sldId id="271"/>
             <p14:sldId id="272"/>
@@ -2525,7 +2525,7 @@
           <a:p>
             <a:r>
               <a:rPr lang="en-US" dirty="0"/>
-              <a:t>To sum up: we built a Bangla-first assistive glass that runs on a Raspberry Pi 5, tested it honestly, and found both what works and what does not yet. Thank you. We are happy to take questions.</a:t>
+              <a:t>To sum up: we built an assistive glass that speaks Bangla, that runs on a Raspberry Pi 5, tested it honestly, and found both what works and what does not yet. Thank you. We are happy to take questions.</a:t>
             </a:r>
             <a:endParaRPr lang="en-US" dirty="0"/>
           </a:p>
@@ -3974,7 +3974,7 @@
                   <a:srgbClr val="A8D5BA"/>
                 </a:solidFill>
               </a:rPr>
-              <a:t>Smart Assistive Reading Aid: an offline, Bangla-first wearable for text reading, object awareness and safe banknote verification</a:t>
+              <a:t>Smart Assistive Reading Aid: An Offline Smart Glass for Visually Impaired People that Reads Bangla and English Text, Detects Objects, and Recognises and Checks Bangladeshi Taka Notes</a:t>
             </a:r>
             <a:endParaRPr lang="en-US" sz="2200" dirty="0"/>
           </a:p>
@@ -8953,7 +8953,7 @@
                   <a:schemeClr val="bg1"/>
                 </a:solidFill>
               </a:rPr>
-              <a:t>A Bangla-first glass that reads, names objects and recognises Taka on a Raspberry Pi 5</a:t>
+              <a:t>An offline glass that speaks Bangla, reads text, names objects and recognises Taka on a Raspberry Pi 5</a:t>
             </a:r>
             <a:endParaRPr lang="en-US" sz="1600" dirty="0"/>
           </a:p>

</xml_diff>

<commit_message>
Second prototype pictures: collage on the title slide and in the thesis (new figure and text), our own close-ups in the hardware table (buttons, headphone, frame, new enclosure row), new SARA thumbnail in the comparison tables, features PDF cover.
Co-Authored-By: Claude Opus 5.5 <noreply@anthropic.com>
</commit_message>
<xml_diff>
--- a/Thesis Report and paper/thesis report/slides/SARA_Presentation.pptx
+++ b/Thesis Report and paper/thesis report/slides/SARA_Presentation.pptx
@@ -131,19 +131,19 @@
   <p:extLst>
     <p:ext uri="{521415D9-36F7-43E2-AB2F-B90AF26B5E84}">
       <p14:sectionLst xmlns:p14="http://schemas.microsoft.com/office/powerpoint/2010/main">
-        <p14:section name="Opening" id="{051d8c28-1aaf-f0bd-f2f6-9fe5e9029997}">
+        <p14:section name="Opening" id="{73b83076-bee3-737f-2367-52d43b78ce25}">
           <p14:sldIdLst>
             <p14:sldId id="256"/>
           </p14:sldIdLst>
         </p14:section>
-        <p14:section name="Problem" id="{43a554c1-3d0e-9fbc-7272-bf00cfb306b2}">
+        <p14:section name="Problem" id="{d1503e30-68c7-5239-6a3f-963fc3b9abea}">
           <p14:sldIdLst>
             <p14:sldId id="257"/>
             <p14:sldId id="258"/>
             <p14:sldId id="259"/>
           </p14:sldIdLst>
         </p14:section>
-        <p14:section name="Solution" id="{5e166af7-85a2-4865-cd5d-690d3890c6ec}">
+        <p14:section name="Solution" id="{ed5267fe-a20a-a537-fc16-8ee980386a23}">
           <p14:sldIdLst>
             <p14:sldId id="260"/>
             <p14:sldId id="261"/>
@@ -152,7 +152,7 @@
             <p14:sldId id="264"/>
           </p14:sldIdLst>
         </p14:section>
-        <p14:section name="Currency" id="{363479ff-6531-629d-1c85-f0895f669f0f}">
+        <p14:section name="Currency" id="{53e0f1e5-df92-b3f5-93ee-e1fb7c19327c}">
           <p14:sldIdLst>
             <p14:sldId id="265"/>
             <p14:sldId id="266"/>
@@ -164,20 +164,20 @@
             <p14:sldId id="272"/>
           </p14:sldIdLst>
         </p14:section>
-        <p14:section name="Reading and voice" id="{08ff1439-54a7-14e1-e553-d91d09e78c53}">
+        <p14:section name="Reading and voice" id="{7f6c0c79-b1e6-174f-5b5f-fbb1d02fe0af}">
           <p14:sldIdLst>
             <p14:sldId id="273"/>
             <p14:sldId id="274"/>
           </p14:sldIdLst>
         </p14:section>
-        <p14:section name="Device" id="{36175add-780b-36ab-dada-70c6ad88a4af}">
+        <p14:section name="Device" id="{6cc8525b-f2f5-27c8-4b8a-a8495df7017a}">
           <p14:sldIdLst>
             <p14:sldId id="275"/>
             <p14:sldId id="276"/>
             <p14:sldId id="277"/>
           </p14:sldIdLst>
         </p14:section>
-        <p14:section name="Closing" id="{e15ba6e2-6c09-60ad-88a3-c62a54fa635b}">
+        <p14:section name="Closing" id="{e804a72d-4201-50e8-e9fb-6c94d6fc7f00}">
           <p14:sldIdLst>
             <p14:sldId id="278"/>
             <p14:sldId id="279"/>
@@ -5113,7 +5113,7 @@
       </p:grpSpPr>
       <p:pic>
         <p:nvPicPr>
-          <p:cNvPr id="2" name="Prototype worn, front" descr="E:\Final SP\Thesis Report and paper\tools\deck\assets/1_1.jpg">    </p:cNvPr>
+          <p:cNvPr id="2" name="Second prototype: front, side and back" descr="E:\Final SP\Thesis Report and paper\tools\deck\assets/v2_collage.jpg">    </p:cNvPr>
           <p:cNvPicPr>
             <a:picLocks noChangeAspect="1"/>
           </p:cNvPicPr>
@@ -5126,8 +5126,8 @@
         </p:blipFill>
         <p:spPr>
           <a:xfrm>
-            <a:off x="7982712" y="0"/>
-            <a:ext cx="4206240" cy="6858000"/>
+            <a:off x="6793992" y="0"/>
+            <a:ext cx="5394960" cy="6858000"/>
           </a:xfrm>
           <a:prstGeom prst="rect">
             <a:avLst/>
@@ -5192,7 +5192,7 @@
         <p:spPr>
           <a:xfrm>
             <a:off x="685800" y="1600200"/>
-            <a:ext cx="6858000" cy="914400"/>
+            <a:ext cx="5669280" cy="914400"/>
           </a:xfrm>
           <a:prstGeom prst="rect">
             <a:avLst/>
@@ -5231,7 +5231,7 @@
         <p:spPr>
           <a:xfrm>
             <a:off x="685800" y="2560320"/>
-            <a:ext cx="6858000" cy="1280160"/>
+            <a:ext cx="5669280" cy="1645920"/>
           </a:xfrm>
           <a:prstGeom prst="rect">
             <a:avLst/>
@@ -5266,8 +5266,8 @@
         </p:nvSpPr>
         <p:spPr>
           <a:xfrm>
-            <a:off x="685800" y="4663440"/>
-            <a:ext cx="6949440" cy="1097280"/>
+            <a:off x="685800" y="4526280"/>
+            <a:ext cx="5760720" cy="1463040"/>
           </a:xfrm>
           <a:prstGeom prst="rect">
             <a:avLst/>
@@ -5291,7 +5291,24 @@
                   <a:srgbClr val="CFE2DA"/>
                 </a:solidFill>
               </a:rPr>
-              <a:t>MD Abdun Fattah Lam (2220014)  ·  Mukut Protim Memo (2020086)  ·  Tanjila Hossain Tapti (2130561)</a:t>
+              <a:t>MD Abdun Fattah Lam (2220014)  ·  Mukut Protim Memo (2020086)</a:t>
+            </a:r>
+            <a:endParaRPr lang="en-US" sz="1300" dirty="0"/>
+          </a:p>
+          <a:p>
+            <a:pPr indent="0" marL="0">
+              <a:spcAft>
+                <a:spcPts val="400"/>
+              </a:spcAft>
+              <a:buNone/>
+            </a:pPr>
+            <a:r>
+              <a:rPr lang="en-US" sz="1300" dirty="0">
+                <a:solidFill>
+                  <a:srgbClr val="CFE2DA"/>
+                </a:solidFill>
+              </a:rPr>
+              <a:t>Tanjila Hossain Tapti (2130561)</a:t>
             </a:r>
             <a:endParaRPr lang="en-US" sz="1300" dirty="0"/>
           </a:p>
@@ -20703,7 +20720,7 @@
       </p:sp>
       <p:pic>
         <p:nvPicPr>
-          <p:cNvPr id="7" name="Side: five buttons, bone-conduction earphone" descr="E:\Final SP\Thesis Report and paper\tools\deck\assets/1_2.jpg">    </p:cNvPr>
+          <p:cNvPr id="7" name="Side: five buttons, bone-conduction earphone" descr="E:\Final SP\Thesis Report and paper\tools\deck\assets/v2_side_portrait.jpg">    </p:cNvPr>
           <p:cNvPicPr>
             <a:picLocks noChangeAspect="1"/>
           </p:cNvPicPr>

</xml_diff>

<commit_message>
The blue light is the UV lamp for the fibre check (thesis text, hardware table, figure caption, slides). Four Bangladeshi counterfeit-detection papers cited in the thesis and slides (Chowdhury et al. ICCA 2022 UV ink; Piyas et al. Data in Brief 2026 JaalTaka; Pathak et al. IJIRCST 2024; Uddin et al. ICIEV 2016), checked against Crossref, and added to the reference spreadsheet.
Co-Authored-By: Claude Opus 5.5 <noreply@anthropic.com>
</commit_message>
<xml_diff>
--- a/Thesis Report and paper/thesis report/slides/SARA_Presentation.pptx
+++ b/Thesis Report and paper/thesis report/slides/SARA_Presentation.pptx
@@ -131,19 +131,19 @@
   <p:extLst>
     <p:ext uri="{521415D9-36F7-43E2-AB2F-B90AF26B5E84}">
       <p14:sectionLst xmlns:p14="http://schemas.microsoft.com/office/powerpoint/2010/main">
-        <p14:section name="Opening" id="{73b83076-bee3-737f-2367-52d43b78ce25}">
+        <p14:section name="Opening" id="{f71352d4-cb90-e2ad-2285-6f1c251677bb}">
           <p14:sldIdLst>
             <p14:sldId id="256"/>
           </p14:sldIdLst>
         </p14:section>
-        <p14:section name="Problem" id="{d1503e30-68c7-5239-6a3f-963fc3b9abea}">
+        <p14:section name="Problem" id="{1b19392e-939b-0906-2a53-b7561541320d}">
           <p14:sldIdLst>
             <p14:sldId id="257"/>
             <p14:sldId id="258"/>
             <p14:sldId id="259"/>
           </p14:sldIdLst>
         </p14:section>
-        <p14:section name="Solution" id="{ed5267fe-a20a-a537-fc16-8ee980386a23}">
+        <p14:section name="Solution" id="{961c3baa-f6aa-fc18-7590-45acee1e6e49}">
           <p14:sldIdLst>
             <p14:sldId id="260"/>
             <p14:sldId id="261"/>
@@ -152,7 +152,7 @@
             <p14:sldId id="264"/>
           </p14:sldIdLst>
         </p14:section>
-        <p14:section name="Currency" id="{53e0f1e5-df92-b3f5-93ee-e1fb7c19327c}">
+        <p14:section name="Currency" id="{45d2a85c-41bd-5404-4e63-b06b0f8f4462}">
           <p14:sldIdLst>
             <p14:sldId id="265"/>
             <p14:sldId id="266"/>
@@ -164,20 +164,20 @@
             <p14:sldId id="272"/>
           </p14:sldIdLst>
         </p14:section>
-        <p14:section name="Reading and voice" id="{7f6c0c79-b1e6-174f-5b5f-fbb1d02fe0af}">
+        <p14:section name="Reading and voice" id="{11df2ad6-7f0c-82af-6cd8-bdf19c669d00}">
           <p14:sldIdLst>
             <p14:sldId id="273"/>
             <p14:sldId id="274"/>
           </p14:sldIdLst>
         </p14:section>
-        <p14:section name="Device" id="{6cc8525b-f2f5-27c8-4b8a-a8495df7017a}">
+        <p14:section name="Device" id="{ea384135-455f-14dd-04ea-58bb32ccc9d5}">
           <p14:sldIdLst>
             <p14:sldId id="275"/>
             <p14:sldId id="276"/>
             <p14:sldId id="277"/>
           </p14:sldIdLst>
         </p14:section>
-        <p14:section name="Closing" id="{e804a72d-4201-50e8-e9fb-6c94d6fc7f00}">
+        <p14:section name="Closing" id="{e9aef73e-6546-704a-e1bf-16f3324e75ab}">
           <p14:sldIdLst>
             <p14:sldId id="278"/>
             <p14:sldId id="279"/>
@@ -6690,7 +6690,7 @@
                   <a:schemeClr val="accent5"/>
                 </a:solidFill>
               </a:rPr>
-              <a:t>Data: [14] Piyas et al., JaalTaka benchmark, Mendeley Data 2025 (1,390 notes, six views each).</a:t>
+              <a:t>Data: [14, 15] Piyas et al., JaalTaka dataset and article, 2025-2026 (1,390 notes, six views each; counterfeits seized by the Rapid Action Battalion).</a:t>
             </a:r>
             <a:endParaRPr lang="en-US" sz="1000" dirty="0"/>
           </a:p>
@@ -6964,7 +6964,7 @@
                   <a:schemeClr val="accent5"/>
                 </a:solidFill>
               </a:rPr>
-              <a:t>Data: [14] JaalTaka; serial-number audit and print-disjoint split are ours.</a:t>
+              <a:t>Data: [14] JaalTaka; serial-number audit and print-disjoint split are ours. Earlier Taka counterfeit work: [16] SVM on security features; [17] CNNs; [19] UV flecks + RPN.</a:t>
             </a:r>
             <a:endParaRPr lang="en-US" sz="1000" dirty="0"/>
           </a:p>
@@ -7340,7 +7340,7 @@
                   <a:schemeClr val="tx1"/>
                 </a:solidFill>
               </a:rPr>
-              <a:t>parameters (0.21 MB): 46× smaller than MobileNetV2 [15]</a:t>
+              <a:t>parameters (0.21 MB): 46× smaller than MobileNetV2 [18]</a:t>
             </a:r>
             <a:endParaRPr lang="en-US" sz="1300" dirty="0"/>
           </a:p>
@@ -7451,7 +7451,7 @@
                   <a:schemeClr val="accent5"/>
                 </a:solidFill>
               </a:rPr>
-              <a:t>Baseline [15] Sandler et al., MobileNetV2, CVPR 2018; data [14] JaalTaka. DMWR (denomination-matched watermark residual) is our method.</a:t>
+              <a:t>Baseline [18] Sandler et al., MobileNetV2, CVPR 2018; data [14] JaalTaka. DMWR (denomination-matched watermark residual) is our method.</a:t>
             </a:r>
             <a:endParaRPr lang="en-US" sz="1000" dirty="0"/>
           </a:p>
@@ -8206,7 +8206,7 @@
                 <a:ea typeface="Cambria" pitchFamily="34" charset="-122"/>
                 <a:cs typeface="Cambria" pitchFamily="34" charset="-120"/>
               </a:rPr>
-              <a:t>UV fibre check: the security fibres light up</a:t>
+              <a:t>UV fibre check: the glass carries its own UV lamp</a:t>
             </a:r>
             <a:endParaRPr lang="en-US" sz="3000" dirty="0"/>
           </a:p>
@@ -8388,7 +8388,43 @@
       </p:sp>
       <p:sp>
         <p:nvSpPr>
-          <p:cNvPr id="8" name="UV caveat"/>
+          <p:cNvPr id="8" name="Sources"/>
+          <p:cNvSpPr txBox="1"/>
+          <p:nvPr/>
+        </p:nvSpPr>
+        <p:spPr>
+          <a:xfrm>
+            <a:off x="548640" y="6053328"/>
+            <a:ext cx="11064240" cy="292608"/>
+          </a:xfrm>
+          <a:prstGeom prst="rect">
+            <a:avLst/>
+          </a:prstGeom>
+          <a:noFill/>
+          <a:ln/>
+        </p:spPr>
+        <p:txBody>
+          <a:bodyPr wrap="square" lIns="0" tIns="0" rIns="0" bIns="0" rtlCol="0" anchor="ctr"/>
+          <a:lstStyle/>
+          <a:p>
+            <a:pPr indent="0" marL="0">
+              <a:buNone/>
+            </a:pPr>
+            <a:r>
+              <a:rPr lang="en-US" sz="1000" i="1" dirty="0">
+                <a:solidFill>
+                  <a:schemeClr val="accent5"/>
+                </a:solidFill>
+              </a:rPr>
+              <a:t>Prior work on Taka under UV light: [19] Chowdhury et al., ICCA 2022 (96.3% with an RPN on UV images). Fibre check (ENFR) and photographs are ours.</a:t>
+            </a:r>
+            <a:endParaRPr lang="en-US" sz="1000" dirty="0"/>
+          </a:p>
+        </p:txBody>
+      </p:sp>
+      <p:sp>
+        <p:nvSpPr>
+          <p:cNvPr id="9" name="UV caveat"/>
           <p:cNvSpPr txBox="1"/>
           <p:nvPr/>
         </p:nvSpPr>
@@ -8769,7 +8805,7 @@
                   <a:schemeClr val="accent5"/>
                 </a:solidFill>
               </a:rPr>
-              <a:t>Engine [6] EasyOCR with [5] CRAFT; real words from [16] ICDAR 2019 MLT (1,000 test words). Every choice made on validation data.</a:t>
+              <a:t>Engine [6] EasyOCR with [5] CRAFT; real words from [20] ICDAR 2019 MLT (1,000 test words). Every choice made on validation data.</a:t>
             </a:r>
             <a:endParaRPr lang="en-US" sz="1000" dirty="0"/>
           </a:p>
@@ -9309,7 +9345,7 @@
                   <a:schemeClr val="accent5"/>
                 </a:solidFill>
               </a:rPr>
-              <a:t>Recogniser [17] Vosk; noise from [18] Piczak, ESC-50; voices [10, 11]. Results: paper_evidence/VOICE_COMMANDS_FAST.md.</a:t>
+              <a:t>Recogniser [21] Vosk; noise from [22] Piczak, ESC-50; voices [10, 11]. Results: paper_evidence/VOICE_COMMANDS_FAST.md.</a:t>
             </a:r>
             <a:endParaRPr lang="en-US" sz="1000" dirty="0"/>
           </a:p>
@@ -12607,28 +12643,6 @@
             </a:r>
             <a:endParaRPr lang="en-US" sz="1100" dirty="0"/>
           </a:p>
-        </p:txBody>
-      </p:sp>
-      <p:sp>
-        <p:nvSpPr>
-          <p:cNvPr id="4" name="References 2"/>
-          <p:cNvSpPr txBox="1"/>
-          <p:nvPr/>
-        </p:nvSpPr>
-        <p:spPr>
-          <a:xfrm>
-            <a:off x="6172200" y="1280160"/>
-            <a:ext cx="5440680" cy="4800600"/>
-          </a:xfrm>
-          <a:prstGeom prst="rect">
-            <a:avLst/>
-          </a:prstGeom>
-          <a:noFill/>
-          <a:ln/>
-        </p:spPr>
-        <p:txBody>
-          <a:bodyPr wrap="square" lIns="0" tIns="0" rIns="0" bIns="0" rtlCol="0" anchor="t"/>
-          <a:lstStyle/>
           <a:p>
             <a:pPr indent="0" marL="0">
               <a:spcAft>
@@ -12663,6 +12677,28 @@
             </a:r>
             <a:endParaRPr lang="en-US" sz="1100" dirty="0"/>
           </a:p>
+        </p:txBody>
+      </p:sp>
+      <p:sp>
+        <p:nvSpPr>
+          <p:cNvPr id="4" name="References 2"/>
+          <p:cNvSpPr txBox="1"/>
+          <p:nvPr/>
+        </p:nvSpPr>
+        <p:spPr>
+          <a:xfrm>
+            <a:off x="6172200" y="1280160"/>
+            <a:ext cx="5440680" cy="4800600"/>
+          </a:xfrm>
+          <a:prstGeom prst="rect">
+            <a:avLst/>
+          </a:prstGeom>
+          <a:noFill/>
+          <a:ln/>
+        </p:spPr>
+        <p:txBody>
+          <a:bodyPr wrap="square" lIns="0" tIns="0" rIns="0" bIns="0" rtlCol="0" anchor="t"/>
+          <a:lstStyle/>
           <a:p>
             <a:pPr indent="0" marL="0">
               <a:spcAft>
@@ -12727,7 +12763,7 @@
                   <a:schemeClr val="tx1"/>
                 </a:solidFill>
               </a:rPr>
-              <a:t>[15]  Sandler, M. et al. MobileNetV2: inverted residuals and linear bottlenecks. CVPR, 2018.</a:t>
+              <a:t>[15]  Piyas, B. R. C. et al. JaalTaka: a benchmark dataset for detecting counterfeit Bangladeshi banknotes. Data in Brief 64, 112377, 2026.</a:t>
             </a:r>
             <a:endParaRPr lang="en-US" sz="1100" dirty="0"/>
           </a:p>
@@ -12744,7 +12780,7 @@
                   <a:schemeClr val="tx1"/>
                 </a:solidFill>
               </a:rPr>
-              <a:t>[16]  Nayef, N. et al. ICDAR2019 robust reading challenge on multi-lingual scene text (RRC-MLT-2019). ICDAR, 2019.</a:t>
+              <a:t>[16]  Uddin, M. S., Das, P. P., Roney, M. S. A. Image-based approach for the detection of counterfeit banknotes of Bangladesh. ICIEV, 2016.</a:t>
             </a:r>
             <a:endParaRPr lang="en-US" sz="1100" dirty="0"/>
           </a:p>
@@ -12761,7 +12797,7 @@
                   <a:schemeClr val="tx1"/>
                 </a:solidFill>
               </a:rPr>
-              <a:t>[17]  Alpha Cephei. Vosk offline speech recognition toolkit.</a:t>
+              <a:t>[17]  Pathak, A. et al. Enhanced counterfeit detection of Bangladesh currency through convolutional neural networks. IJIRCST 12(2), 2024.</a:t>
             </a:r>
             <a:endParaRPr lang="en-US" sz="1100" dirty="0"/>
           </a:p>
@@ -12778,7 +12814,75 @@
                   <a:schemeClr val="tx1"/>
                 </a:solidFill>
               </a:rPr>
-              <a:t>[18]  Piczak, K. J. ESC: dataset for environmental sound classification. ACM Multimedia, 2015.</a:t>
+              <a:t>[18]  Sandler, M. et al. MobileNetV2: inverted residuals and linear bottlenecks. CVPR, 2018.</a:t>
+            </a:r>
+            <a:endParaRPr lang="en-US" sz="1100" dirty="0"/>
+          </a:p>
+          <a:p>
+            <a:pPr indent="0" marL="0">
+              <a:spcAft>
+                <a:spcPts val="500"/>
+              </a:spcAft>
+              <a:buNone/>
+            </a:pPr>
+            <a:r>
+              <a:rPr lang="en-US" sz="1100" dirty="0">
+                <a:solidFill>
+                  <a:schemeClr val="tx1"/>
+                </a:solidFill>
+              </a:rPr>
+              <a:t>[19]  Chowdhury, A. A. et al. Evaluation of deep learning models on UV ink: a fake money detection scheme with RPN. ICCA (ACM), 2022.</a:t>
+            </a:r>
+            <a:endParaRPr lang="en-US" sz="1100" dirty="0"/>
+          </a:p>
+          <a:p>
+            <a:pPr indent="0" marL="0">
+              <a:spcAft>
+                <a:spcPts val="500"/>
+              </a:spcAft>
+              <a:buNone/>
+            </a:pPr>
+            <a:r>
+              <a:rPr lang="en-US" sz="1100" dirty="0">
+                <a:solidFill>
+                  <a:schemeClr val="tx1"/>
+                </a:solidFill>
+              </a:rPr>
+              <a:t>[20]  Nayef, N. et al. ICDAR2019 robust reading challenge on multi-lingual scene text (RRC-MLT-2019). ICDAR, 2019.</a:t>
+            </a:r>
+            <a:endParaRPr lang="en-US" sz="1100" dirty="0"/>
+          </a:p>
+          <a:p>
+            <a:pPr indent="0" marL="0">
+              <a:spcAft>
+                <a:spcPts val="500"/>
+              </a:spcAft>
+              <a:buNone/>
+            </a:pPr>
+            <a:r>
+              <a:rPr lang="en-US" sz="1100" dirty="0">
+                <a:solidFill>
+                  <a:schemeClr val="tx1"/>
+                </a:solidFill>
+              </a:rPr>
+              <a:t>[21]  Alpha Cephei. Vosk offline speech recognition toolkit.</a:t>
+            </a:r>
+            <a:endParaRPr lang="en-US" sz="1100" dirty="0"/>
+          </a:p>
+          <a:p>
+            <a:pPr indent="0" marL="0">
+              <a:spcAft>
+                <a:spcPts val="500"/>
+              </a:spcAft>
+              <a:buNone/>
+            </a:pPr>
+            <a:r>
+              <a:rPr lang="en-US" sz="1100" dirty="0">
+                <a:solidFill>
+                  <a:schemeClr val="tx1"/>
+                </a:solidFill>
+              </a:rPr>
+              <a:t>[22]  Piczak, K. J. ESC: dataset for environmental sound classification. ACM Multimedia, 2015.</a:t>
             </a:r>
             <a:endParaRPr lang="en-US" sz="1100" dirty="0"/>
           </a:p>
@@ -20661,7 +20765,7 @@
       </p:sp>
       <p:pic>
         <p:nvPicPr>
-          <p:cNvPr id="5" name="Front: camera and LED on the bridge" descr="E:\Final SP\Thesis Report and paper\tools\deck\assets/1_20.jpg">    </p:cNvPr>
+          <p:cNvPr id="5" name="Front: camera and UV lamp (blue light)" descr="E:\Final SP\Thesis Report and paper\tools\deck\assets/1_20.jpg">    </p:cNvPr>
           <p:cNvPicPr>
             <a:picLocks noChangeAspect="1"/>
           </p:cNvPicPr>
@@ -20712,7 +20816,7 @@
                   <a:schemeClr val="accent5"/>
                 </a:solidFill>
               </a:rPr>
-              <a:t>Front: camera and LED on the bridge</a:t>
+              <a:t>Front: camera and UV lamp (blue light)</a:t>
             </a:r>
             <a:endParaRPr lang="en-US" sz="1200" dirty="0"/>
           </a:p>

</xml_diff>

<commit_message>
UV check: the glass's lamp is 360-395 nm; 365 nm inspection, non-glowing banknote paper and optical brighteners cited from Mutanen et al. (IS&T PICS 2003), the ECB quick guide (2010) and US patent 6,918,482; paper added to the reference spreadsheet.
Co-Authored-By: Claude Opus 5.5 <noreply@anthropic.com>
</commit_message>
<xml_diff>
--- a/Thesis Report and paper/thesis report/slides/SARA_Presentation.pptx
+++ b/Thesis Report and paper/thesis report/slides/SARA_Presentation.pptx
@@ -131,19 +131,19 @@
   <p:extLst>
     <p:ext uri="{521415D9-36F7-43E2-AB2F-B90AF26B5E84}">
       <p14:sectionLst xmlns:p14="http://schemas.microsoft.com/office/powerpoint/2010/main">
-        <p14:section name="Opening" id="{f71352d4-cb90-e2ad-2285-6f1c251677bb}">
+        <p14:section name="Opening" id="{2bf96422-0567-58c3-2575-3fa2b3b695e6}">
           <p14:sldIdLst>
             <p14:sldId id="256"/>
           </p14:sldIdLst>
         </p14:section>
-        <p14:section name="Problem" id="{1b19392e-939b-0906-2a53-b7561541320d}">
+        <p14:section name="Problem" id="{08978f1b-9606-4ac2-fdbe-e9db9638c4c9}">
           <p14:sldIdLst>
             <p14:sldId id="257"/>
             <p14:sldId id="258"/>
             <p14:sldId id="259"/>
           </p14:sldIdLst>
         </p14:section>
-        <p14:section name="Solution" id="{961c3baa-f6aa-fc18-7590-45acee1e6e49}">
+        <p14:section name="Solution" id="{99067a14-0c4c-3960-289a-2fcde1bb5a0a}">
           <p14:sldIdLst>
             <p14:sldId id="260"/>
             <p14:sldId id="261"/>
@@ -152,7 +152,7 @@
             <p14:sldId id="264"/>
           </p14:sldIdLst>
         </p14:section>
-        <p14:section name="Currency" id="{45d2a85c-41bd-5404-4e63-b06b0f8f4462}">
+        <p14:section name="Currency" id="{3f702cab-29e5-7953-d5e2-94b3c49e999a}">
           <p14:sldIdLst>
             <p14:sldId id="265"/>
             <p14:sldId id="266"/>
@@ -164,20 +164,20 @@
             <p14:sldId id="272"/>
           </p14:sldIdLst>
         </p14:section>
-        <p14:section name="Reading and voice" id="{11df2ad6-7f0c-82af-6cd8-bdf19c669d00}">
+        <p14:section name="Reading and voice" id="{c8c1939f-2e84-1788-bf46-1a272bd7650d}">
           <p14:sldIdLst>
             <p14:sldId id="273"/>
             <p14:sldId id="274"/>
           </p14:sldIdLst>
         </p14:section>
-        <p14:section name="Device" id="{ea384135-455f-14dd-04ea-58bb32ccc9d5}">
+        <p14:section name="Device" id="{ea2661e4-f4c6-1334-9c4c-d975e68fcaf1}">
           <p14:sldIdLst>
             <p14:sldId id="275"/>
             <p14:sldId id="276"/>
             <p14:sldId id="277"/>
           </p14:sldIdLst>
         </p14:section>
-        <p14:section name="Closing" id="{e9aef73e-6546-704a-e1bf-16f3324e75ab}">
+        <p14:section name="Closing" id="{52686d80-f57a-024e-cfa3-e04424d05064}">
           <p14:sldIdLst>
             <p14:sldId id="278"/>
             <p14:sldId id="279"/>
@@ -8416,7 +8416,7 @@
                   <a:schemeClr val="accent5"/>
                 </a:solidFill>
               </a:rPr>
-              <a:t>Prior work on Taka under UV light: [19] Chowdhury et al., ICCA 2022 (96.3% with an RPN on UV images). Fibre check (ENFR) and photographs are ours.</a:t>
+              <a:t>The glass's lamp emits 360-395 nm, covering the 365 nm used for banknote checks; banknote paper stays dark while its fibres glow [20]. Prior Taka UV work: [19] (96.3%). Fibre check and photos are ours.</a:t>
             </a:r>
             <a:endParaRPr lang="en-US" sz="1000" dirty="0"/>
           </a:p>
@@ -8805,7 +8805,7 @@
                   <a:schemeClr val="accent5"/>
                 </a:solidFill>
               </a:rPr>
-              <a:t>Engine [6] EasyOCR with [5] CRAFT; real words from [20] ICDAR 2019 MLT (1,000 test words). Every choice made on validation data.</a:t>
+              <a:t>Engine [6] EasyOCR with [5] CRAFT; real words from [21] ICDAR 2019 MLT (1,000 test words). Every choice made on validation data.</a:t>
             </a:r>
             <a:endParaRPr lang="en-US" sz="1000" dirty="0"/>
           </a:p>
@@ -9345,7 +9345,7 @@
                   <a:schemeClr val="accent5"/>
                 </a:solidFill>
               </a:rPr>
-              <a:t>Recogniser [21] Vosk; noise from [22] Piczak, ESC-50; voices [10, 11]. Results: paper_evidence/VOICE_COMMANDS_FAST.md.</a:t>
+              <a:t>Recogniser [22] Vosk; noise from [23] Piczak, ESC-50; voices [10, 11]. Results: paper_evidence/VOICE_COMMANDS_FAST.md.</a:t>
             </a:r>
             <a:endParaRPr lang="en-US" sz="1000" dirty="0"/>
           </a:p>
@@ -12677,28 +12677,6 @@
             </a:r>
             <a:endParaRPr lang="en-US" sz="1100" dirty="0"/>
           </a:p>
-        </p:txBody>
-      </p:sp>
-      <p:sp>
-        <p:nvSpPr>
-          <p:cNvPr id="4" name="References 2"/>
-          <p:cNvSpPr txBox="1"/>
-          <p:nvPr/>
-        </p:nvSpPr>
-        <p:spPr>
-          <a:xfrm>
-            <a:off x="6172200" y="1280160"/>
-            <a:ext cx="5440680" cy="4800600"/>
-          </a:xfrm>
-          <a:prstGeom prst="rect">
-            <a:avLst/>
-          </a:prstGeom>
-          <a:noFill/>
-          <a:ln/>
-        </p:spPr>
-        <p:txBody>
-          <a:bodyPr wrap="square" lIns="0" tIns="0" rIns="0" bIns="0" rtlCol="0" anchor="t"/>
-          <a:lstStyle/>
           <a:p>
             <a:pPr indent="0" marL="0">
               <a:spcAft>
@@ -12716,6 +12694,28 @@
             </a:r>
             <a:endParaRPr lang="en-US" sz="1100" dirty="0"/>
           </a:p>
+        </p:txBody>
+      </p:sp>
+      <p:sp>
+        <p:nvSpPr>
+          <p:cNvPr id="4" name="References 2"/>
+          <p:cNvSpPr txBox="1"/>
+          <p:nvPr/>
+        </p:nvSpPr>
+        <p:spPr>
+          <a:xfrm>
+            <a:off x="6172200" y="1280160"/>
+            <a:ext cx="5440680" cy="4800600"/>
+          </a:xfrm>
+          <a:prstGeom prst="rect">
+            <a:avLst/>
+          </a:prstGeom>
+          <a:noFill/>
+          <a:ln/>
+        </p:spPr>
+        <p:txBody>
+          <a:bodyPr wrap="square" lIns="0" tIns="0" rIns="0" bIns="0" rtlCol="0" anchor="t"/>
+          <a:lstStyle/>
           <a:p>
             <a:pPr indent="0" marL="0">
               <a:spcAft>
@@ -12848,7 +12848,7 @@
                   <a:schemeClr val="tx1"/>
                 </a:solidFill>
               </a:rPr>
-              <a:t>[20]  Nayef, N. et al. ICDAR2019 robust reading challenge on multi-lingual scene text (RRC-MLT-2019). ICDAR, 2019.</a:t>
+              <a:t>[20]  Mutanen, J., Jaaskelainen, T., Parkkinen, J. P. S. Luminescent security properties of banknotes. IS&amp;T PICS Conference, 2003, pp. 421-424.</a:t>
             </a:r>
             <a:endParaRPr lang="en-US" sz="1100" dirty="0"/>
           </a:p>
@@ -12865,7 +12865,7 @@
                   <a:schemeClr val="tx1"/>
                 </a:solidFill>
               </a:rPr>
-              <a:t>[21]  Alpha Cephei. Vosk offline speech recognition toolkit.</a:t>
+              <a:t>[21]  Nayef, N. et al. ICDAR2019 robust reading challenge on multi-lingual scene text (RRC-MLT-2019). ICDAR, 2019.</a:t>
             </a:r>
             <a:endParaRPr lang="en-US" sz="1100" dirty="0"/>
           </a:p>
@@ -12882,7 +12882,24 @@
                   <a:schemeClr val="tx1"/>
                 </a:solidFill>
               </a:rPr>
-              <a:t>[22]  Piczak, K. J. ESC: dataset for environmental sound classification. ACM Multimedia, 2015.</a:t>
+              <a:t>[22]  Alpha Cephei. Vosk offline speech recognition toolkit.</a:t>
+            </a:r>
+            <a:endParaRPr lang="en-US" sz="1100" dirty="0"/>
+          </a:p>
+          <a:p>
+            <a:pPr indent="0" marL="0">
+              <a:spcAft>
+                <a:spcPts val="500"/>
+              </a:spcAft>
+              <a:buNone/>
+            </a:pPr>
+            <a:r>
+              <a:rPr lang="en-US" sz="1100" dirty="0">
+                <a:solidFill>
+                  <a:schemeClr val="tx1"/>
+                </a:solidFill>
+              </a:rPr>
+              <a:t>[23]  Piczak, K. J. ESC: dataset for environmental sound classification. ACM Multimedia, 2015.</a:t>
             </a:r>
             <a:endParaRPr lang="en-US" sz="1100" dirty="0"/>
           </a:p>

</xml_diff>